<commit_message>
Add EU funding logo across all formats
Introduce a shared `ppadem-funding.lua` flow and `eu-logo.png` asset so every output ends with the EU/ERC funding logo, including a dedicated final slide for PowerPoint and end-of-document placement for HTML, Word, slides, and brief outputs. Wire the filter and resources into all relevant extensions, add shared styling, and update the brief Typst template.

Update brand sync tooling to distribute the new logo and Lua filter, extend Office template builders/reference files to include the funding logo, add cleanup support in `justfile`, and refresh README/office template docs plus license wording to document the new behavior.
</commit_message>
<xml_diff>
--- a/_extensions/ppadem-powerpoint/ppadem-reference.pptx
+++ b/_extensions/ppadem-powerpoint/ppadem-reference.pptx
@@ -1149,6 +1149,30 @@
           </a:p>
         </p:txBody>
       </p:sp>
+      <p:pic>
+        <p:nvPicPr>
+          <p:cNvPr id="6" name="EU logo" descr="Funded by the European Union. European Research Council"/>
+          <p:cNvPicPr>
+            <a:picLocks noChangeAspect="1"/>
+          </p:cNvPicPr>
+          <p:nvPr userDrawn="1"/>
+        </p:nvPicPr>
+        <p:blipFill>
+          <a:blip r:embed="rId3"/>
+          <a:stretch>
+            <a:fillRect/>
+          </a:stretch>
+        </p:blipFill>
+        <p:spPr>
+          <a:xfrm>
+            <a:off x="5034282" y="5486400"/>
+            <a:ext cx="2123132" cy="914400"/>
+          </a:xfrm>
+          <a:prstGeom prst="rect">
+            <a:avLst/>
+          </a:prstGeom>
+        </p:spPr>
+      </p:pic>
     </p:spTree>
   </p:cSld>
   <p:clrMapOvr>

</xml_diff>